<commit_message>
Add screenshots into presentation slides
- Slide 4: DAG graph view screenshot
- Slide 7: Metabase dashboard screenshots (2)
- Slide 9: Airflow grid screenshot
- PNG images embedded in the pptx file
</commit_message>
<xml_diff>
--- a/presentation_forex_pipeline_v2.pptx
+++ b/presentation_forex_pipeline_v2.pptx
@@ -5502,6 +5502,30 @@
           </a:p>
         </p:txBody>
       </p:sp>
+      <p:pic>
+        <p:nvPicPr>
+          <p:cNvPr id="15" name="Picture 14" descr="01_airflow_graph.png"/>
+          <p:cNvPicPr>
+            <a:picLocks noChangeAspect="1"/>
+          </p:cNvPicPr>
+          <p:nvPr/>
+        </p:nvPicPr>
+        <p:blipFill>
+          <a:blip r:embed="rId2"/>
+          <a:stretch>
+            <a:fillRect/>
+          </a:stretch>
+        </p:blipFill>
+        <p:spPr>
+          <a:xfrm>
+            <a:off x="457200" y="5486400"/>
+            <a:ext cx="10972800" cy="1188720"/>
+          </a:xfrm>
+          <a:prstGeom prst="rect">
+            <a:avLst/>
+          </a:prstGeom>
+        </p:spPr>
+      </p:pic>
     </p:spTree>
   </p:cSld>
   <p:clrMapOvr>
@@ -6690,6 +6714,54 @@
           </a:p>
         </p:txBody>
       </p:sp>
+      <p:pic>
+        <p:nvPicPr>
+          <p:cNvPr id="7" name="Picture 6" descr="06_metabase_dashboard1.png"/>
+          <p:cNvPicPr>
+            <a:picLocks noChangeAspect="1"/>
+          </p:cNvPicPr>
+          <p:nvPr/>
+        </p:nvPicPr>
+        <p:blipFill>
+          <a:blip r:embed="rId2"/>
+          <a:stretch>
+            <a:fillRect/>
+          </a:stretch>
+        </p:blipFill>
+        <p:spPr>
+          <a:xfrm>
+            <a:off x="731520" y="4572000"/>
+            <a:ext cx="5029200" cy="2103120"/>
+          </a:xfrm>
+          <a:prstGeom prst="rect">
+            <a:avLst/>
+          </a:prstGeom>
+        </p:spPr>
+      </p:pic>
+      <p:pic>
+        <p:nvPicPr>
+          <p:cNvPr id="8" name="Picture 7" descr="07_metabase_dashboard2.png"/>
+          <p:cNvPicPr>
+            <a:picLocks noChangeAspect="1"/>
+          </p:cNvPicPr>
+          <p:nvPr/>
+        </p:nvPicPr>
+        <p:blipFill>
+          <a:blip r:embed="rId3"/>
+          <a:stretch>
+            <a:fillRect/>
+          </a:stretch>
+        </p:blipFill>
+        <p:spPr>
+          <a:xfrm>
+            <a:off x="6217920" y="4572000"/>
+            <a:ext cx="5029200" cy="2103120"/>
+          </a:xfrm>
+          <a:prstGeom prst="rect">
+            <a:avLst/>
+          </a:prstGeom>
+        </p:spPr>
+      </p:pic>
     </p:spTree>
   </p:cSld>
   <p:clrMapOvr>
@@ -7469,6 +7541,30 @@
           </a:p>
         </p:txBody>
       </p:sp>
+      <p:pic>
+        <p:nvPicPr>
+          <p:cNvPr id="7" name="Picture 6" descr="03_airflow_grid.png"/>
+          <p:cNvPicPr>
+            <a:picLocks noChangeAspect="1"/>
+          </p:cNvPicPr>
+          <p:nvPr/>
+        </p:nvPicPr>
+        <p:blipFill>
+          <a:blip r:embed="rId2"/>
+          <a:stretch>
+            <a:fillRect/>
+          </a:stretch>
+        </p:blipFill>
+        <p:spPr>
+          <a:xfrm>
+            <a:off x="914400" y="4572000"/>
+            <a:ext cx="10058400" cy="2011680"/>
+          </a:xfrm>
+          <a:prstGeom prst="rect">
+            <a:avLst/>
+          </a:prstGeom>
+        </p:spPr>
+      </p:pic>
     </p:spTree>
   </p:cSld>
   <p:clrMapOvr>

</xml_diff>